<commit_message>
Presentación de cierre: retira montos y referencia a la Dirección de la lámina 2 y de la lámina 12
Co-Authored-By: Claude Fable 5.1 <noreply@anthropic.com>
Claude-Session: https://claude.ai/code/session_01EMti6dkWbm1pxhqSrisvbv
</commit_message>
<xml_diff>
--- a/entregables-2026-10-09/Sports-World-Cierre-justo-2026-10-09.pptx
+++ b/entregables-2026-10-09/Sports-World-Cierre-justo-2026-10-09.pptx
@@ -121,19 +121,19 @@
   <p:extLst>
     <p:ext uri="{521415D9-36F7-43E2-AB2F-B90AF26B5E84}">
       <p14:sectionLst xmlns:p14="http://schemas.microsoft.com/office/powerpoint/2010/main">
-        <p14:section name="Apertura" id="{879d2467-f3eb-550a-b307-c113d243bd8b}">
+        <p14:section name="Apertura" id="{b2d466af-6aa4-b487-a108-d1bae3dde505}">
           <p14:sldIdLst>
             <p14:sldId id="256"/>
             <p14:sldId id="257"/>
           </p14:sldIdLst>
         </p14:section>
-        <p14:section name="Hechos" id="{19ed4bd6-a3c8-0d1c-2f33-9d448639f3ad}">
+        <p14:section name="Hechos" id="{9a378660-0f90-7f69-f525-db463c3726a3}">
           <p14:sldIdLst>
             <p14:sldId id="258"/>
             <p14:sldId id="259"/>
           </p14:sldIdLst>
         </p14:section>
-        <p14:section name="Razones" id="{59d54b06-cb44-142b-2e79-86ad13064abc}">
+        <p14:section name="Razones" id="{e20d0438-7d16-2b6a-25f1-4df44e5271f8}">
           <p14:sldIdLst>
             <p14:sldId id="260"/>
             <p14:sldId id="261"/>
@@ -141,14 +141,14 @@
             <p14:sldId id="263"/>
           </p14:sldIdLst>
         </p14:section>
-        <p14:section name="Lo entregado" id="{e50121b3-8d7a-7129-3caa-04797f238f5f}">
+        <p14:section name="Lo entregado" id="{67e878c6-c395-e388-76c1-8112dfd38912}">
           <p14:sldIdLst>
             <p14:sldId id="264"/>
             <p14:sldId id="265"/>
             <p14:sldId id="266"/>
           </p14:sldIdLst>
         </p14:section>
-        <p14:section name="Cierre" id="{0a1e3d22-61fa-a237-441e-c8e613a37859}">
+        <p14:section name="Cierre" id="{349068e8-d2f7-0dc5-e86c-d629ce1e6292}">
           <p14:sldIdLst>
             <p14:sldId id="267"/>
             <p14:sldId id="268"/>
@@ -824,7 +824,7 @@
           <a:p>
             <a:r>
               <a:rPr lang="en-US" dirty="0"/>
-              <a:t>No pedimos una concesión: tomamos la palabra de la Dirección del 7 de octubre como punto de partida. Buscamos un cierre justo y rápido; lo documentado permite sostenerlo donde sea necesario.</a:t>
+              <a:t>El trabajo se hizo a petición expresa, con autorización interna comunicada y con visto bueno de Sistemas. Los entregables son propiedad de Final Upgrade. Buscamos un cierre justo y rápido; lo documentado permite sostenerlo donde sea necesario.</a:t>
             </a:r>
             <a:endParaRPr lang="en-US" dirty="0"/>
           </a:p>
@@ -1176,7 +1176,7 @@
           <a:p>
             <a:r>
               <a:rPr lang="en-US" dirty="0"/>
-              <a:t>Lo que sigue sustenta estas tres afirmaciones con fechas y documentos. La propuesta final está en la lámina 13.</a:t>
+              <a:t>Lo que sigue sustenta estas tres afirmaciones con fechas y documentos. Las cifras de la propuesta se presentan al final, en la lámina 13, después del valor de lo entregado.</a:t>
             </a:r>
             <a:endParaRPr lang="en-US" dirty="0"/>
           </a:p>
@@ -7897,7 +7897,7 @@
                   <a:schemeClr val="tx1"/>
                 </a:solidFill>
               </a:rPr>
-              <a:t>Partimos de la posición de Sports World</a:t>
+              <a:t>Lo que sostiene la propuesta</a:t>
             </a:r>
             <a:endParaRPr lang="en-US" sz="3000" dirty="0"/>
           </a:p>
@@ -7963,7 +7963,7 @@
                 <a:ea typeface="Cambria" pitchFamily="34" charset="-122"/>
                 <a:cs typeface="Cambria" pitchFamily="34" charset="-120"/>
               </a:rPr>
-              <a:t>«Vamos a negociar si le pagamos su diseño o algo para que no le pierda tanto.»</a:t>
+              <a:t>Sports World solicitó por escrito veinte entregables entre marzo y septiembre; todos fueron atendidos.</a:t>
             </a:r>
             <a:endParaRPr lang="en-US" sz="1400" dirty="0"/>
           </a:p>
@@ -7999,7 +7999,7 @@
                   <a:schemeClr val="tx2"/>
                 </a:solidFill>
               </a:rPr>
-              <a:t>Dirección de Sports World, 7 de octubre de 2026</a:t>
+              <a:t>Correspondencia entre Final Upgrade y Sports World, 2026</a:t>
             </a:r>
             <a:endParaRPr lang="en-US" sz="1100" dirty="0"/>
           </a:p>
@@ -11505,7 +11505,7 @@
                   <a:schemeClr val="tx1"/>
                 </a:solidFill>
               </a:rPr>
-              <a:t>Sports World ya planteó compensar el trabajo</a:t>
+              <a:t>Todo se produjo a petición expresa de Sports World</a:t>
             </a:r>
             <a:endParaRPr lang="en-US" sz="1600" dirty="0"/>
           </a:p>
@@ -11541,7 +11541,7 @@
                   <a:schemeClr val="tx2"/>
                 </a:solidFill>
               </a:rPr>
-              <a:t>El 7 de octubre la Dirección propuso negociar el pago del diseño. El 29 de septiembre Sistemas otorgó su visto bueno al contrato final.</a:t>
+              <a:t>Veinte solicitudes por escrito entre marzo y septiembre, todas atendidas, con el precio en la mesa desde el 29 de abril y el contrato final entregado el 29 de septiembre.</a:t>
             </a:r>
             <a:endParaRPr lang="en-US" sz="1250" dirty="0"/>
           </a:p>
@@ -11556,11 +11556,11 @@
         <p:spPr>
           <a:xfrm>
             <a:off x="548640" y="4297680"/>
-            <a:ext cx="11091672" cy="1783080"/>
+            <a:ext cx="11091672" cy="1463040"/>
           </a:xfrm>
           <a:prstGeom prst="roundRect">
             <a:avLst>
-              <a:gd name="adj" fmla="val 4103"/>
+              <a:gd name="adj" fmla="val 5000"/>
             </a:avLst>
           </a:prstGeom>
           <a:solidFill>
@@ -11576,14 +11576,14 @@
       </p:sp>
       <p:sp>
         <p:nvSpPr>
-          <p:cNvPr id="15" name="n1"/>
+          <p:cNvPr id="15" name="bandaTxt"/>
           <p:cNvSpPr txBox="1"/>
           <p:nvPr/>
         </p:nvSpPr>
         <p:spPr>
           <a:xfrm>
             <a:off x="914400" y="4434840"/>
-            <a:ext cx="5120640" cy="731520"/>
+            <a:ext cx="10360152" cy="1188720"/>
           </a:xfrm>
           <a:prstGeom prst="rect">
             <a:avLst/>
@@ -11599,7 +11599,7 @@
               <a:buNone/>
             </a:pPr>
             <a:r>
-              <a:rPr lang="en-US" sz="3400" dirty="0">
+              <a:rPr lang="en-US" sz="2000" dirty="0">
                 <a:solidFill>
                   <a:schemeClr val="bg1"/>
                 </a:solidFill>
@@ -11607,120 +11607,9 @@
                 <a:ea typeface="Cambria" pitchFamily="34" charset="-122"/>
                 <a:cs typeface="Cambria" pitchFamily="34" charset="-120"/>
               </a:rPr>
-              <a:t>350,000 MXN</a:t>
+              <a:t>Propuesta: un cierre justo por lo entregado, acreditable en su totalidad si el proyecto se retoma, o la adquisición de todas las etapas.</a:t>
             </a:r>
-            <a:endParaRPr lang="en-US" sz="3400" dirty="0"/>
-          </a:p>
-        </p:txBody>
-      </p:sp>
-      <p:sp>
-        <p:nvSpPr>
-          <p:cNvPr id="16" name="n1p"/>
-          <p:cNvSpPr txBox="1"/>
-          <p:nvPr/>
-        </p:nvSpPr>
-        <p:spPr>
-          <a:xfrm>
-            <a:off x="914400" y="5166360"/>
-            <a:ext cx="5120640" cy="822960"/>
-          </a:xfrm>
-          <a:prstGeom prst="rect">
-            <a:avLst/>
-          </a:prstGeom>
-          <a:noFill/>
-          <a:ln/>
-        </p:spPr>
-        <p:txBody>
-          <a:bodyPr wrap="square" lIns="0" tIns="0" rIns="0" bIns="0" rtlCol="0" anchor="ctr"/>
-          <a:lstStyle/>
-          <a:p>
-            <a:pPr indent="0" marL="0">
-              <a:buNone/>
-            </a:pPr>
-            <a:r>
-              <a:rPr lang="en-US" sz="1250" dirty="0">
-                <a:solidFill>
-                  <a:schemeClr val="accent3"/>
-                </a:solidFill>
-              </a:rPr>
-              <a:t>Compensación por lo entregado, pago inmediato, 100 % acreditable si el proyecto se retoma.</a:t>
-            </a:r>
-            <a:endParaRPr lang="en-US" sz="1250" dirty="0"/>
-          </a:p>
-        </p:txBody>
-      </p:sp>
-      <p:sp>
-        <p:nvSpPr>
-          <p:cNvPr id="17" name="n2"/>
-          <p:cNvSpPr txBox="1"/>
-          <p:nvPr/>
-        </p:nvSpPr>
-        <p:spPr>
-          <a:xfrm>
-            <a:off x="6583680" y="4434840"/>
-            <a:ext cx="5120640" cy="731520"/>
-          </a:xfrm>
-          <a:prstGeom prst="rect">
-            <a:avLst/>
-          </a:prstGeom>
-          <a:noFill/>
-          <a:ln/>
-        </p:spPr>
-        <p:txBody>
-          <a:bodyPr wrap="square" lIns="0" tIns="0" rIns="0" bIns="0" rtlCol="0" anchor="ctr"/>
-          <a:lstStyle/>
-          <a:p>
-            <a:pPr indent="0" marL="0">
-              <a:buNone/>
-            </a:pPr>
-            <a:r>
-              <a:rPr lang="en-US" sz="3400" dirty="0">
-                <a:solidFill>
-                  <a:schemeClr val="bg1"/>
-                </a:solidFill>
-                <a:latin typeface="Cambria" pitchFamily="34" charset="0"/>
-                <a:ea typeface="Cambria" pitchFamily="34" charset="-122"/>
-                <a:cs typeface="Cambria" pitchFamily="34" charset="-120"/>
-              </a:rPr>
-              <a:t>650,000 MXN</a:t>
-            </a:r>
-            <a:endParaRPr lang="en-US" sz="3400" dirty="0"/>
-          </a:p>
-        </p:txBody>
-      </p:sp>
-      <p:sp>
-        <p:nvSpPr>
-          <p:cNvPr id="18" name="n2p"/>
-          <p:cNvSpPr txBox="1"/>
-          <p:nvPr/>
-        </p:nvSpPr>
-        <p:spPr>
-          <a:xfrm>
-            <a:off x="6583680" y="5166360"/>
-            <a:ext cx="5120640" cy="822960"/>
-          </a:xfrm>
-          <a:prstGeom prst="rect">
-            <a:avLst/>
-          </a:prstGeom>
-          <a:noFill/>
-          <a:ln/>
-        </p:spPr>
-        <p:txBody>
-          <a:bodyPr wrap="square" lIns="0" tIns="0" rIns="0" bIns="0" rtlCol="0" anchor="ctr"/>
-          <a:lstStyle/>
-          <a:p>
-            <a:pPr indent="0" marL="0">
-              <a:buNone/>
-            </a:pPr>
-            <a:r>
-              <a:rPr lang="en-US" sz="1250" dirty="0">
-                <a:solidFill>
-                  <a:schemeClr val="accent3"/>
-                </a:solidFill>
-              </a:rPr>
-              <a:t>Adquisición de todos los entregables de todas las etapas, con cesión de derechos de uso.</a:t>
-            </a:r>
-            <a:endParaRPr lang="en-US" sz="1250" dirty="0"/>
+            <a:endParaRPr lang="en-US" sz="2000" dirty="0"/>
           </a:p>
         </p:txBody>
       </p:sp>

</xml_diff>

<commit_message>
Presentación de cierre: valuación de entregables ajustada a 649,100 MXN
Co-Authored-By: Claude Fable 5.1 <noreply@anthropic.com>
Claude-Session: https://claude.ai/code/session_01EMti6dkWbm1pxhqSrisvbv
</commit_message>
<xml_diff>
--- a/entregables-2026-10-09/Sports-World-Cierre-justo-2026-10-09.pptx
+++ b/entregables-2026-10-09/Sports-World-Cierre-justo-2026-10-09.pptx
@@ -121,19 +121,19 @@
   <p:extLst>
     <p:ext uri="{521415D9-36F7-43E2-AB2F-B90AF26B5E84}">
       <p14:sectionLst xmlns:p14="http://schemas.microsoft.com/office/powerpoint/2010/main">
-        <p14:section name="Apertura" id="{b2d466af-6aa4-b487-a108-d1bae3dde505}">
+        <p14:section name="Apertura" id="{3a8297bb-97b6-a256-f536-19b80e3a8c67}">
           <p14:sldIdLst>
             <p14:sldId id="256"/>
             <p14:sldId id="257"/>
           </p14:sldIdLst>
         </p14:section>
-        <p14:section name="Hechos" id="{9a378660-0f90-7f69-f525-db463c3726a3}">
+        <p14:section name="Hechos" id="{ce33240a-9094-fde4-19cb-da8b9a2872a2}">
           <p14:sldIdLst>
             <p14:sldId id="258"/>
             <p14:sldId id="259"/>
           </p14:sldIdLst>
         </p14:section>
-        <p14:section name="Razones" id="{e20d0438-7d16-2b6a-25f1-4df44e5271f8}">
+        <p14:section name="Razones" id="{4519f614-d057-87fe-ad86-2d20ebe67154}">
           <p14:sldIdLst>
             <p14:sldId id="260"/>
             <p14:sldId id="261"/>
@@ -141,14 +141,14 @@
             <p14:sldId id="263"/>
           </p14:sldIdLst>
         </p14:section>
-        <p14:section name="Lo entregado" id="{67e878c6-c395-e388-76c1-8112dfd38912}">
+        <p14:section name="Lo entregado" id="{4cd3ab65-3956-7e9d-58fd-9951bdd56c61}">
           <p14:sldIdLst>
             <p14:sldId id="264"/>
             <p14:sldId id="265"/>
             <p14:sldId id="266"/>
           </p14:sldIdLst>
         </p14:section>
-        <p14:section name="Cierre" id="{349068e8-d2f7-0dc5-e86c-d629ce1e6292}">
+        <p14:section name="Cierre" id="{a3978498-70cc-ec0b-c0a4-efa6488612a6}">
           <p14:sldIdLst>
             <p14:sldId id="267"/>
             <p14:sldId id="268"/>
@@ -736,7 +736,7 @@
           <a:p>
             <a:r>
               <a:rPr lang="en-US" dirty="0"/>
-              <a:t>Cada entregable está valuado a la tarifa horaria que el propio contrato fija: 75 dólares, 1,335 pesos. Las horas son conservadoras. El valor del trabajo supera el millón de pesos, más 35 mil pesos de honorarios legales por la revisión y redacción de cuatro versiones del contrato, dos addenda y los contratos separados. Nada de esto se ha facturado.</a:t>
+              <a:t>Cada entregable está valuado a la tarifa horaria que el propio contrato fija: 75 dólares, 1,335 pesos. Las horas son conservadoras. El valor del trabajo es de 614 mil pesos, más 35 mil pesos de honorarios legales por la revisión y redacción de cuatro versiones del contrato, dos addenda y los contratos separados. Nada de esto se ha facturado.</a:t>
             </a:r>
             <a:endParaRPr lang="en-US" dirty="0"/>
           </a:p>
@@ -912,7 +912,7 @@
           <a:p>
             <a:r>
               <a:rPr lang="en-US" dirty="0"/>
-              <a:t>Opción 1: 350 mil pesos de compensación, pago inmediato, acreditables al 100 por ciento si el proyecto se retoma. Opción 2: 650 mil pesos por todo el trabajo de todas las etapas, con cesión de uso. Las dos cifras están por debajo del costo real del trabajo.</a:t>
+              <a:t>Opción 1: 350 mil pesos de compensación, pago inmediato, acreditables al 100 por ciento si el proyecto se retoma. Opción 2: 650 mil pesos por todo el trabajo de todas las etapas, con cesión de uso. La Opción 2 paga el valor de lo entregado a la tarifa del contrato, sin margen adicional; la Opción 1 es 54 por ciento de ese valor.</a:t>
             </a:r>
             <a:endParaRPr lang="en-US" dirty="0"/>
           </a:p>
@@ -5279,7 +5279,7 @@
                             <a:schemeClr val="tx1"/>
                           </a:solidFill>
                         </a:rPr>
-                        <a:t>40</a:t>
+                        <a:t>24</a:t>
                       </a:r>
                       <a:endParaRPr lang="en-US" sz="1150" dirty="0"/>
                     </a:p>
@@ -5340,7 +5340,7 @@
                             <a:schemeClr val="tx1"/>
                           </a:solidFill>
                         </a:rPr>
-                        <a:t>53,400</a:t>
+                        <a:t>32,040</a:t>
                       </a:r>
                       <a:endParaRPr lang="en-US" sz="1150" dirty="0"/>
                     </a:p>
@@ -5525,7 +5525,7 @@
                             <a:schemeClr val="tx1"/>
                           </a:solidFill>
                         </a:rPr>
-                        <a:t>48</a:t>
+                        <a:t>28</a:t>
                       </a:r>
                       <a:endParaRPr lang="en-US" sz="1150" dirty="0"/>
                     </a:p>
@@ -5586,7 +5586,7 @@
                             <a:schemeClr val="tx1"/>
                           </a:solidFill>
                         </a:rPr>
-                        <a:t>64,080</a:t>
+                        <a:t>37,380</a:t>
                       </a:r>
                       <a:endParaRPr lang="en-US" sz="1150" dirty="0"/>
                     </a:p>
@@ -5771,7 +5771,7 @@
                             <a:schemeClr val="tx1"/>
                           </a:solidFill>
                         </a:rPr>
-                        <a:t>56</a:t>
+                        <a:t>32</a:t>
                       </a:r>
                       <a:endParaRPr lang="en-US" sz="1150" dirty="0"/>
                     </a:p>
@@ -5832,7 +5832,7 @@
                             <a:schemeClr val="tx1"/>
                           </a:solidFill>
                         </a:rPr>
-                        <a:t>74,760</a:t>
+                        <a:t>42,720</a:t>
                       </a:r>
                       <a:endParaRPr lang="en-US" sz="1150" dirty="0"/>
                     </a:p>
@@ -6017,7 +6017,7 @@
                             <a:schemeClr val="tx1"/>
                           </a:solidFill>
                         </a:rPr>
-                        <a:t>160</a:t>
+                        <a:t>96</a:t>
                       </a:r>
                       <a:endParaRPr lang="en-US" sz="1150" dirty="0"/>
                     </a:p>
@@ -6078,7 +6078,7 @@
                             <a:schemeClr val="tx1"/>
                           </a:solidFill>
                         </a:rPr>
-                        <a:t>213,600</a:t>
+                        <a:t>128,160</a:t>
                       </a:r>
                       <a:endParaRPr lang="en-US" sz="1150" dirty="0"/>
                     </a:p>
@@ -6263,7 +6263,7 @@
                             <a:schemeClr val="tx1"/>
                           </a:solidFill>
                         </a:rPr>
-                        <a:t>48</a:t>
+                        <a:t>28</a:t>
                       </a:r>
                       <a:endParaRPr lang="en-US" sz="1150" dirty="0"/>
                     </a:p>
@@ -6324,7 +6324,7 @@
                             <a:schemeClr val="tx1"/>
                           </a:solidFill>
                         </a:rPr>
-                        <a:t>64,080</a:t>
+                        <a:t>37,380</a:t>
                       </a:r>
                       <a:endParaRPr lang="en-US" sz="1150" dirty="0"/>
                     </a:p>
@@ -6509,7 +6509,7 @@
                             <a:schemeClr val="tx1"/>
                           </a:solidFill>
                         </a:rPr>
-                        <a:t>128</a:t>
+                        <a:t>72</a:t>
                       </a:r>
                       <a:endParaRPr lang="en-US" sz="1150" dirty="0"/>
                     </a:p>
@@ -6570,7 +6570,7 @@
                             <a:schemeClr val="tx1"/>
                           </a:solidFill>
                         </a:rPr>
-                        <a:t>170,880</a:t>
+                        <a:t>96,120</a:t>
                       </a:r>
                       <a:endParaRPr lang="en-US" sz="1150" dirty="0"/>
                     </a:p>
@@ -6755,7 +6755,7 @@
                             <a:schemeClr val="tx1"/>
                           </a:solidFill>
                         </a:rPr>
-                        <a:t>160</a:t>
+                        <a:t>96</a:t>
                       </a:r>
                       <a:endParaRPr lang="en-US" sz="1150" dirty="0"/>
                     </a:p>
@@ -6816,7 +6816,7 @@
                             <a:schemeClr val="tx1"/>
                           </a:solidFill>
                         </a:rPr>
-                        <a:t>213,600</a:t>
+                        <a:t>128,160</a:t>
                       </a:r>
                       <a:endParaRPr lang="en-US" sz="1150" dirty="0"/>
                     </a:p>
@@ -7001,7 +7001,7 @@
                             <a:schemeClr val="tx1"/>
                           </a:solidFill>
                         </a:rPr>
-                        <a:t>48</a:t>
+                        <a:t>28</a:t>
                       </a:r>
                       <a:endParaRPr lang="en-US" sz="1150" dirty="0"/>
                     </a:p>
@@ -7062,7 +7062,7 @@
                             <a:schemeClr val="tx1"/>
                           </a:solidFill>
                         </a:rPr>
-                        <a:t>64,080</a:t>
+                        <a:t>37,380</a:t>
                       </a:r>
                       <a:endParaRPr lang="en-US" sz="1150" dirty="0"/>
                     </a:p>
@@ -7247,7 +7247,7 @@
                             <a:schemeClr val="tx1"/>
                           </a:solidFill>
                         </a:rPr>
-                        <a:t>40</a:t>
+                        <a:t>24</a:t>
                       </a:r>
                       <a:endParaRPr lang="en-US" sz="1150" dirty="0"/>
                     </a:p>
@@ -7308,7 +7308,7 @@
                             <a:schemeClr val="tx1"/>
                           </a:solidFill>
                         </a:rPr>
-                        <a:t>53,400</a:t>
+                        <a:t>32,040</a:t>
                       </a:r>
                       <a:endParaRPr lang="en-US" sz="1150" dirty="0"/>
                     </a:p>
@@ -7493,7 +7493,7 @@
                             <a:schemeClr val="tx1"/>
                           </a:solidFill>
                         </a:rPr>
-                        <a:t>60</a:t>
+                        <a:t>32</a:t>
                       </a:r>
                       <a:endParaRPr lang="en-US" sz="1150" dirty="0"/>
                     </a:p>
@@ -7554,7 +7554,7 @@
                             <a:schemeClr val="tx1"/>
                           </a:solidFill>
                         </a:rPr>
-                        <a:t>80,100</a:t>
+                        <a:t>42,720</a:t>
                       </a:r>
                       <a:endParaRPr lang="en-US" sz="1150" dirty="0"/>
                     </a:p>
@@ -7663,7 +7663,7 @@
                   <a:schemeClr val="accent3"/>
                 </a:solidFill>
               </a:rPr>
-              <a:t>788 horas × 1,335 MXN = </a:t>
+              <a:t>460 horas × 1,335 MXN = </a:t>
             </a:r>
             <a:pPr indent="0" marL="0">
               <a:buNone/>
@@ -7674,7 +7674,7 @@
                   <a:schemeClr val="accent3"/>
                 </a:solidFill>
               </a:rPr>
-              <a:t>1,051,980 MXN</a:t>
+              <a:t>614,100 MXN</a:t>
             </a:r>
             <a:endParaRPr lang="en-US" sz="1300" dirty="0"/>
           </a:p>
@@ -7760,7 +7760,7 @@
                 <a:ea typeface="Cambria" pitchFamily="34" charset="-122"/>
                 <a:cs typeface="Cambria" pitchFamily="34" charset="-120"/>
               </a:rPr>
-              <a:t>1,086,980 MXN</a:t>
+              <a:t>649,100 MXN</a:t>
             </a:r>
             <a:endParaRPr lang="en-US" sz="2600" dirty="0"/>
           </a:p>
@@ -8692,7 +8692,7 @@
                   <a:schemeClr val="tx2"/>
                 </a:solidFill>
               </a:rPr>
-              <a:t>Equivale a 32 % del valor de lo entregado (1,086,980 MXN). Deja abierta la relación y el proyecto listo para arrancar.</a:t>
+              <a:t>Equivale a 54 % del valor de lo entregado (649,100 MXN). Deja abierta la relación y el proyecto listo para arrancar.</a:t>
             </a:r>
             <a:endParaRPr lang="en-US" sz="1250" dirty="0"/>
           </a:p>
@@ -8924,7 +8924,7 @@
                   <a:schemeClr val="tx2"/>
                 </a:solidFill>
               </a:rPr>
-              <a:t>Equivale a 60 % del valor de lo entregado y a 37 % del contrato final de 1,742,600 MXN.</a:t>
+              <a:t>Cubre el valor íntegro de lo entregado (649,100 MXN) y equivale a 37 % del contrato final de 1,742,600 MXN.</a:t>
             </a:r>
             <a:endParaRPr lang="en-US" sz="1250" dirty="0"/>
           </a:p>

</xml_diff>

<commit_message>
Presentación de cierre: retira la referencia al visto bueno de Sistemas
Co-Authored-By: Claude Fable 5.1 <noreply@anthropic.com>
Claude-Session: https://claude.ai/code/session_01EMti6dkWbm1pxhqSrisvbv
</commit_message>
<xml_diff>
--- a/entregables-2026-10-09/Sports-World-Cierre-justo-2026-10-09.pptx
+++ b/entregables-2026-10-09/Sports-World-Cierre-justo-2026-10-09.pptx
@@ -121,19 +121,19 @@
   <p:extLst>
     <p:ext uri="{521415D9-36F7-43E2-AB2F-B90AF26B5E84}">
       <p14:sectionLst xmlns:p14="http://schemas.microsoft.com/office/powerpoint/2010/main">
-        <p14:section name="Apertura" id="{3a8297bb-97b6-a256-f536-19b80e3a8c67}">
+        <p14:section name="Apertura" id="{0039355d-054f-4420-7e84-0f76abf9b99b}">
           <p14:sldIdLst>
             <p14:sldId id="256"/>
             <p14:sldId id="257"/>
           </p14:sldIdLst>
         </p14:section>
-        <p14:section name="Hechos" id="{ce33240a-9094-fde4-19cb-da8b9a2872a2}">
+        <p14:section name="Hechos" id="{aaaaec3d-0b0e-33bd-cc40-b399cbd352e9}">
           <p14:sldIdLst>
             <p14:sldId id="258"/>
             <p14:sldId id="259"/>
           </p14:sldIdLst>
         </p14:section>
-        <p14:section name="Razones" id="{4519f614-d057-87fe-ad86-2d20ebe67154}">
+        <p14:section name="Razones" id="{9e1d1b25-5313-4f8c-9e2a-355c1243f5fe}">
           <p14:sldIdLst>
             <p14:sldId id="260"/>
             <p14:sldId id="261"/>
@@ -141,14 +141,14 @@
             <p14:sldId id="263"/>
           </p14:sldIdLst>
         </p14:section>
-        <p14:section name="Lo entregado" id="{4cd3ab65-3956-7e9d-58fd-9951bdd56c61}">
+        <p14:section name="Lo entregado" id="{808d1d30-317c-086c-9c36-10c148ea475c}">
           <p14:sldIdLst>
             <p14:sldId id="264"/>
             <p14:sldId id="265"/>
             <p14:sldId id="266"/>
           </p14:sldIdLst>
         </p14:section>
-        <p14:section name="Cierre" id="{a3978498-70cc-ec0b-c0a4-efa6488612a6}">
+        <p14:section name="Cierre" id="{39d143bc-84bd-7104-a245-20bf374602b3}">
           <p14:sldIdLst>
             <p14:sldId id="267"/>
             <p14:sldId id="268"/>
@@ -824,7 +824,7 @@
           <a:p>
             <a:r>
               <a:rPr lang="en-US" dirty="0"/>
-              <a:t>El trabajo se hizo a petición expresa, con autorización interna comunicada y con visto bueno de Sistemas. Los entregables son propiedad de Final Upgrade. Buscamos un cierre justo y rápido; lo documentado permite sostenerlo donde sea necesario.</a:t>
+              <a:t>El trabajo se hizo a petición expresa, con autorización interna comunicada y con el contrato final en manos de Legal. Los entregables son propiedad de Final Upgrade. Buscamos un cierre justo y rápido; lo documentado permite sostenerlo donde sea necesario.</a:t>
             </a:r>
             <a:endParaRPr lang="en-US" dirty="0"/>
           </a:p>
@@ -1352,7 +1352,7 @@
           <a:p>
             <a:r>
               <a:rPr lang="en-US" dirty="0"/>
-              <a:t>Siete meses desde el diagnóstico. Cinco meses desde que el precio fue conocido y autorizado internamente. Cuatro reducciones de alcance a petición de Sports World. La objeción de precio aparece al final, después de que el contrato ya tenía el visto bueno de Sistemas.</a:t>
+              <a:t>Siete meses desde el diagnóstico. Cinco meses desde que el precio fue conocido y autorizado internamente. Cuatro reducciones de alcance a petición de Sports World. La objeción de precio aparece al final, después de que el contrato final ya estaba en manos de Legal.</a:t>
             </a:r>
             <a:endParaRPr lang="en-US" dirty="0"/>
           </a:p>
@@ -8065,7 +8065,7 @@
                 <a:ea typeface="Cambria" pitchFamily="34" charset="-122"/>
                 <a:cs typeface="Cambria" pitchFamily="34" charset="-120"/>
               </a:rPr>
-              <a:t>Sistemas otorga su visto bueno al contrato final y Legal lo recibe para firma.</a:t>
+              <a:t>Legal de Sports World recibe el contrato final para firma.</a:t>
             </a:r>
             <a:endParaRPr lang="en-US" sz="1400" dirty="0"/>
           </a:p>
@@ -15315,7 +15315,7 @@
                             <a:schemeClr val="tx1"/>
                           </a:solidFill>
                         </a:rPr>
-                        <a:t>Legal recibe el contrato final; Sistemas otorga su visto bueno</a:t>
+                        <a:t>Legal recibe el contrato final para firma</a:t>
                       </a:r>
                       <a:endParaRPr lang="en-US" sz="1150" dirty="0"/>
                     </a:p>

</xml_diff>